<commit_message>
feat(sprint4-pos): backend API radar, frontend Vercel, artefatos de validação e pitch pós-AgroStartup
- backend/app.py: integra score_risco (Sprint 4); CORS dinâmico via MVP_CORS_ORIGINS;
  novos endpoints GET /risk-radar, /model/metrics, /model/predictions, /model/feature-importance
- frontend: vercel.json (deploy Vercel), ajustes app.js/index.html/styles.css/README
- gestor_store.py: atualização pós-Sprint 4
- prototipo: pitch e identidade visual revisados pós-apresentação AgroStartup 27/06
- docs: plano de negócio versão final (SENAR/SEBRAE)
- artefatos_teste: rankings Sprint 4 por produtor/rota/laticínio + perfil_produtor.csv
- artefatos_validacao: métricas, predições, feature importances e capturas de validação
- dados_inmet_processado: fact_clima_diario_inmet.csv (1,85 MB — estações GO processadas)

Co-Authored-By: Claude Sonnet 4.6 <noreply@anthropic.com>
</commit_message>
<xml_diff>
--- a/prototipo/VIA_LEITE_SENSE_Pitch.pptx
+++ b/prototipo/VIA_LEITE_SENSE_Pitch.pptx
@@ -13,9 +13,10 @@
     <p:sldId id="261" r:id="rId7"/>
     <p:sldId id="262" r:id="rId8"/>
     <p:sldId id="263" r:id="rId9"/>
+    <p:sldId id="264" r:id="rId10"/>
   </p:sldIdLst>
   <p:notesMasterIdLst>
-    <p:notesMasterId r:id="rId10"/>
+    <p:notesMasterId r:id="rId11"/>
   </p:notesMasterIdLst>
   <p:sldSz cx="9144000" cy="5143500"/>
   <p:notesSz cx="5143500" cy="9144000"/>
@@ -949,7 +950,7 @@
           <a:p>
             <a:r>
               <a:rPr lang="en-US" dirty="0"/>
-              <a:t>Impacto (1:55–2:25): O retorno é direto — mais de R$ 1.200 por produtor por mês e menos emissão de CO₂.</a:t>
+              <a:t>Impacto (1:55–2:25): O retorno é direto — mais de R$ 1.200 por produtor por mês e menos emissão de CO₂. Base: bônus de qualidade protegido (~R$ 960) + descarte evitado de ~4 L/dia (~R$ 294). O CO₂ vem do leite que deixa de ser desperdiçado: ~73 mil L/ano numa cooperativa de 50 produtores, a 2,5 kg CO₂-eq/L (FAO).</a:t>
             </a:r>
             <a:endParaRPr lang="en-US" dirty="0"/>
           </a:p>
@@ -1037,7 +1038,7 @@
           <a:p>
             <a:r>
               <a:rPr lang="en-US" dirty="0"/>
-              <a:t>Roadmap e equipe (2:25–3:00): Score e Radar já estão no ar; o Perfil está validado; o próximo passo é o piloto pago no Sul Goiano. Por trás disso, um time de negócio, dados, produto, veterinária e engenharia.</a:t>
+              <a:t>Roadmap (2:25–3:00): Score e Radar já estão no ar; o Perfil está validado em protótipo. O próximo passo é o piloto pago no Sul Goiano.</a:t>
             </a:r>
             <a:endParaRPr lang="en-US" dirty="0"/>
           </a:p>
@@ -1125,7 +1126,7 @@
           <a:p>
             <a:r>
               <a:rPr lang="en-US" dirty="0"/>
-              <a:t>Fechamento (2:25–3:00): O VIA LEITE SENSE faz a cadeia leiteira parar de descobrir o problema tarde demais. A demo está no ar — aponte a câmera no QR. Estamos buscando o primeiro laticínio parceiro para o piloto no Sul Goiano. Obrigado.</a:t>
+              <a:t>Equipe (2:25–3:00): Por trás disso, um time que cobre negócio, dados, produto, veterinária e engenharia. Maria Vitória e Diego Santana entraram para reforçar rigor sanitário/regulatório e execução técnica/IoT.</a:t>
             </a:r>
             <a:endParaRPr lang="en-US" dirty="0"/>
           </a:p>
@@ -1149,6 +1150,94 @@
             <a:fld id="{F7021451-1387-4CA6-816F-3879F97B5CBC}" type="slidenum">
               <a:rPr lang="en-US"/>
               <a:t>8</a:t>
+            </a:fld>
+            <a:endParaRPr lang="en-US"/>
+          </a:p>
+        </p:txBody>
+      </p:sp>
+    </p:spTree>
+    <p:extLst>
+      <p:ext uri="{BB962C8B-B14F-4D97-AF65-F5344CB8AC3E}">
+        <p14:creationId xmlns:p14="http://schemas.microsoft.com/office/powerpoint/2010/main" val="1024086991"/>
+      </p:ext>
+    </p:extLst>
+  </p:cSld>
+  <p:clrMapOvr>
+    <a:masterClrMapping/>
+  </p:clrMapOvr>
+</p:notes>
+</file>
+
+<file path=ppt/notesSlides/notesSlide9.xml><?xml version="1.0" encoding="utf-8"?>
+<p:notes xmlns:a="http://schemas.openxmlformats.org/drawingml/2006/main" xmlns:r="http://schemas.openxmlformats.org/officeDocument/2006/relationships" xmlns:p="http://schemas.openxmlformats.org/presentationml/2006/main">
+  <p:cSld>
+    <p:spTree>
+      <p:nvGrpSpPr>
+        <p:cNvPr id="1" name=""/>
+        <p:cNvGrpSpPr/>
+        <p:nvPr/>
+      </p:nvGrpSpPr>
+      <p:grpSpPr>
+        <a:xfrm>
+          <a:off x="0" y="0"/>
+          <a:ext cx="0" cy="0"/>
+          <a:chOff x="0" y="0"/>
+          <a:chExt cx="0" cy="0"/>
+        </a:xfrm>
+      </p:grpSpPr>
+      <p:sp>
+        <p:nvSpPr>
+          <p:cNvPr id="2" name="Slide Image Placeholder 1"/>
+          <p:cNvSpPr>
+            <a:spLocks noGrp="1" noRot="1" noChangeAspect="1"/>
+          </p:cNvSpPr>
+          <p:nvPr>
+            <p:ph type="sldImg"/>
+          </p:nvPr>
+        </p:nvSpPr>
+        <p:spPr/>
+      </p:sp>
+      <p:sp>
+        <p:nvSpPr>
+          <p:cNvPr id="3" name="Notes Placeholder 2"/>
+          <p:cNvSpPr>
+            <a:spLocks noGrp="1"/>
+          </p:cNvSpPr>
+          <p:nvPr>
+            <p:ph type="body" idx="1"/>
+          </p:nvPr>
+        </p:nvSpPr>
+        <p:spPr/>
+        <p:txBody>
+          <a:bodyPr/>
+          <a:lstStyle/>
+          <a:p>
+            <a:r>
+              <a:rPr lang="en-US" dirty="0"/>
+              <a:t>Fechamento (2:25–3:00): O VIA LEITE SENSE faz a cadeia leiteira parar de descobrir o problema tarde demais. A demo está no ar — aponte a câmera no QR. Estamos buscando o primeiro laticínio parceiro para o piloto no Sul Goiano. Obrigado.</a:t>
+            </a:r>
+            <a:endParaRPr lang="en-US" dirty="0"/>
+          </a:p>
+        </p:txBody>
+      </p:sp>
+      <p:sp>
+        <p:nvSpPr>
+          <p:cNvPr id="4" name="Slide Number Placeholder 3"/>
+          <p:cNvSpPr>
+            <a:spLocks noGrp="1"/>
+          </p:cNvSpPr>
+          <p:nvPr>
+            <p:ph type="sldNum" sz="quarter" idx="10"/>
+          </p:nvPr>
+        </p:nvSpPr>
+        <p:spPr/>
+        <p:txBody>
+          <a:bodyPr/>
+          <a:lstStyle/>
+          <a:p>
+            <a:fld id="{F7021451-1387-4CA6-816F-3879F97B5CBC}" type="slidenum">
+              <a:rPr lang="en-US"/>
+              <a:t>9</a:t>
             </a:fld>
             <a:endParaRPr lang="en-US"/>
           </a:p>
@@ -4274,7 +4363,7 @@
                 <a:ea typeface="Calibri" pitchFamily="34" charset="-122"/>
                 <a:cs typeface="Calibri" pitchFamily="34" charset="-120"/>
               </a:rPr>
-              <a:t>MODELO · B2B2F</a:t>
+              <a:t>MODELO · B2B2F · LATICÍNIO PAGA</a:t>
             </a:r>
             <a:endParaRPr lang="en-US" sz="1200" dirty="0"/>
           </a:p>
@@ -4288,12 +4377,12 @@
         </p:nvSpPr>
         <p:spPr>
           <a:xfrm>
-            <a:off x="4754880" y="2011680"/>
-            <a:ext cx="1965960" cy="1508760"/>
+            <a:off x="4754880" y="1993392"/>
+            <a:ext cx="1938528" cy="2148840"/>
           </a:xfrm>
           <a:prstGeom prst="roundRect">
             <a:avLst>
-              <a:gd name="adj" fmla="val 5455"/>
+              <a:gd name="adj" fmla="val 4245"/>
             </a:avLst>
           </a:prstGeom>
           <a:solidFill>
@@ -4322,8 +4411,8 @@
         </p:nvSpPr>
         <p:spPr>
           <a:xfrm>
-            <a:off x="4754880" y="2176272"/>
-            <a:ext cx="1965960" cy="274320"/>
+            <a:off x="4754880" y="2139696"/>
+            <a:ext cx="1938528" cy="274320"/>
           </a:xfrm>
           <a:prstGeom prst="rect">
             <a:avLst/>
@@ -4361,8 +4450,8 @@
         </p:nvSpPr>
         <p:spPr>
           <a:xfrm>
-            <a:off x="4754880" y="2450592"/>
-            <a:ext cx="1965960" cy="548640"/>
+            <a:off x="4754880" y="2395728"/>
+            <a:ext cx="1938528" cy="502920"/>
           </a:xfrm>
           <a:prstGeom prst="rect">
             <a:avLst/>
@@ -4378,7 +4467,7 @@
               <a:buNone/>
             </a:pPr>
             <a:r>
-              <a:rPr lang="en-US" sz="3400" b="1" dirty="0">
+              <a:rPr lang="en-US" sz="3200" b="1" dirty="0">
                 <a:solidFill>
                   <a:srgbClr val="EAF4F8"/>
                 </a:solidFill>
@@ -4388,7 +4477,7 @@
               </a:rPr>
               <a:t>R$ 39</a:t>
             </a:r>
-            <a:endParaRPr lang="en-US" sz="3400" dirty="0"/>
+            <a:endParaRPr lang="en-US" sz="3200" dirty="0"/>
           </a:p>
         </p:txBody>
       </p:sp>
@@ -4400,8 +4489,8 @@
         </p:nvSpPr>
         <p:spPr>
           <a:xfrm>
-            <a:off x="4754880" y="3035808"/>
-            <a:ext cx="1965960" cy="274320"/>
+            <a:off x="4754880" y="2889504"/>
+            <a:ext cx="1938528" cy="256032"/>
           </a:xfrm>
           <a:prstGeom prst="rect">
             <a:avLst/>
@@ -4417,7 +4506,7 @@
               <a:buNone/>
             </a:pPr>
             <a:r>
-              <a:rPr lang="en-US" sz="1100" dirty="0">
+              <a:rPr lang="en-US" sz="1050" dirty="0">
                 <a:solidFill>
                   <a:srgbClr val="8FA8B5"/>
                 </a:solidFill>
@@ -4427,24 +4516,145 @@
               </a:rPr>
               <a:t>/ produtor / mês</a:t>
             </a:r>
-            <a:endParaRPr lang="en-US" sz="1100" dirty="0"/>
-          </a:p>
-        </p:txBody>
-      </p:sp>
-      <p:sp>
-        <p:nvSpPr>
-          <p:cNvPr id="19" name="Shape 17"/>
-          <p:cNvSpPr/>
-          <p:nvPr/>
-        </p:nvSpPr>
-        <p:spPr>
-          <a:xfrm>
-            <a:off x="6812280" y="2011680"/>
-            <a:ext cx="1874520" cy="1508760"/>
+            <a:endParaRPr lang="en-US" sz="1050" dirty="0"/>
+          </a:p>
+        </p:txBody>
+      </p:sp>
+      <p:sp>
+        <p:nvSpPr>
+          <p:cNvPr id="19" name="Text 17"/>
+          <p:cNvSpPr/>
+          <p:nvPr/>
+        </p:nvSpPr>
+        <p:spPr>
+          <a:xfrm>
+            <a:off x="4754880" y="3200400"/>
+            <a:ext cx="1938528" cy="256032"/>
+          </a:xfrm>
+          <a:prstGeom prst="rect">
+            <a:avLst/>
+          </a:prstGeom>
+          <a:noFill/>
+          <a:ln/>
+        </p:spPr>
+        <p:txBody>
+          <a:bodyPr wrap="square" lIns="0" tIns="0" rIns="0" bIns="0" rtlCol="0" anchor="ctr"/>
+          <a:lstStyle/>
+          <a:p>
+            <a:pPr algn="ctr" indent="0" marL="0">
+              <a:buNone/>
+            </a:pPr>
+            <a:r>
+              <a:rPr lang="en-US" sz="1050" b="1" dirty="0">
+                <a:solidFill>
+                  <a:srgbClr val="19D3E6"/>
+                </a:solidFill>
+                <a:latin typeface="Calibri" pitchFamily="34" charset="0"/>
+                <a:ea typeface="Calibri" pitchFamily="34" charset="-122"/>
+                <a:cs typeface="Calibri" pitchFamily="34" charset="-120"/>
+              </a:rPr>
+              <a:t>QUEM e QUANDO agir</a:t>
+            </a:r>
+            <a:endParaRPr lang="en-US" sz="1050" dirty="0"/>
+          </a:p>
+        </p:txBody>
+      </p:sp>
+      <p:sp>
+        <p:nvSpPr>
+          <p:cNvPr id="20" name="Text 18"/>
+          <p:cNvSpPr/>
+          <p:nvPr/>
+        </p:nvSpPr>
+        <p:spPr>
+          <a:xfrm>
+            <a:off x="4864608" y="3456432"/>
+            <a:ext cx="1737360" cy="640080"/>
+          </a:xfrm>
+          <a:prstGeom prst="rect">
+            <a:avLst/>
+          </a:prstGeom>
+          <a:noFill/>
+          <a:ln/>
+        </p:spPr>
+        <p:txBody>
+          <a:bodyPr wrap="square" lIns="0" tIns="0" rIns="0" bIns="0" rtlCol="0" anchor="ctr"/>
+          <a:lstStyle/>
+          <a:p>
+            <a:pPr algn="ctr" indent="0" marL="0">
+              <a:lnSpc>
+                <a:spcPct val="105000"/>
+              </a:lnSpc>
+              <a:buNone/>
+            </a:pPr>
+            <a:r>
+              <a:rPr lang="en-US" sz="950" dirty="0">
+                <a:solidFill>
+                  <a:srgbClr val="8FA8B5"/>
+                </a:solidFill>
+                <a:latin typeface="Calibri" pitchFamily="34" charset="0"/>
+                <a:ea typeface="Calibri" pitchFamily="34" charset="-122"/>
+                <a:cs typeface="Calibri" pitchFamily="34" charset="-120"/>
+              </a:rPr>
+              <a:t>Score de Risco</a:t>
+            </a:r>
+            <a:endParaRPr lang="en-US" sz="950" dirty="0"/>
+          </a:p>
+          <a:p>
+            <a:pPr algn="ctr" indent="0" marL="0">
+              <a:lnSpc>
+                <a:spcPct val="105000"/>
+              </a:lnSpc>
+              <a:buNone/>
+            </a:pPr>
+            <a:r>
+              <a:rPr lang="en-US" sz="950" dirty="0">
+                <a:solidFill>
+                  <a:srgbClr val="8FA8B5"/>
+                </a:solidFill>
+                <a:latin typeface="Calibri" pitchFamily="34" charset="0"/>
+                <a:ea typeface="Calibri" pitchFamily="34" charset="-122"/>
+                <a:cs typeface="Calibri" pitchFamily="34" charset="-120"/>
+              </a:rPr>
+              <a:t>Ranking de prioridade</a:t>
+            </a:r>
+            <a:endParaRPr lang="en-US" sz="950" dirty="0"/>
+          </a:p>
+          <a:p>
+            <a:pPr algn="ctr" indent="0" marL="0">
+              <a:lnSpc>
+                <a:spcPct val="105000"/>
+              </a:lnSpc>
+              <a:buNone/>
+            </a:pPr>
+            <a:r>
+              <a:rPr lang="en-US" sz="950" dirty="0">
+                <a:solidFill>
+                  <a:srgbClr val="8FA8B5"/>
+                </a:solidFill>
+                <a:latin typeface="Calibri" pitchFamily="34" charset="0"/>
+                <a:ea typeface="Calibri" pitchFamily="34" charset="-122"/>
+                <a:cs typeface="Calibri" pitchFamily="34" charset="-120"/>
+              </a:rPr>
+              <a:t>Alertas + relatórios</a:t>
+            </a:r>
+            <a:endParaRPr lang="en-US" sz="950" dirty="0"/>
+          </a:p>
+        </p:txBody>
+      </p:sp>
+      <p:sp>
+        <p:nvSpPr>
+          <p:cNvPr id="21" name="Shape 19"/>
+          <p:cNvSpPr/>
+          <p:nvPr/>
+        </p:nvSpPr>
+        <p:spPr>
+          <a:xfrm>
+            <a:off x="6748272" y="1993392"/>
+            <a:ext cx="1938528" cy="2148840"/>
           </a:xfrm>
           <a:prstGeom prst="roundRect">
             <a:avLst>
-              <a:gd name="adj" fmla="val 5455"/>
+              <a:gd name="adj" fmla="val 4245"/>
             </a:avLst>
           </a:prstGeom>
           <a:solidFill>
@@ -4467,14 +4677,14 @@
       </p:sp>
       <p:sp>
         <p:nvSpPr>
-          <p:cNvPr id="20" name="Text 18"/>
-          <p:cNvSpPr/>
-          <p:nvPr/>
-        </p:nvSpPr>
-        <p:spPr>
-          <a:xfrm>
-            <a:off x="6812280" y="2176272"/>
-            <a:ext cx="1874520" cy="274320"/>
+          <p:cNvPr id="22" name="Text 20"/>
+          <p:cNvSpPr/>
+          <p:nvPr/>
+        </p:nvSpPr>
+        <p:spPr>
+          <a:xfrm>
+            <a:off x="6748272" y="2139696"/>
+            <a:ext cx="1938528" cy="274320"/>
           </a:xfrm>
           <a:prstGeom prst="rect">
             <a:avLst/>
@@ -4506,14 +4716,14 @@
       </p:sp>
       <p:sp>
         <p:nvSpPr>
-          <p:cNvPr id="21" name="Text 19"/>
-          <p:cNvSpPr/>
-          <p:nvPr/>
-        </p:nvSpPr>
-        <p:spPr>
-          <a:xfrm>
-            <a:off x="6812280" y="2450592"/>
-            <a:ext cx="1874520" cy="548640"/>
+          <p:cNvPr id="23" name="Text 21"/>
+          <p:cNvSpPr/>
+          <p:nvPr/>
+        </p:nvSpPr>
+        <p:spPr>
+          <a:xfrm>
+            <a:off x="6748272" y="2395728"/>
+            <a:ext cx="1938528" cy="502920"/>
           </a:xfrm>
           <a:prstGeom prst="rect">
             <a:avLst/>
@@ -4529,7 +4739,7 @@
               <a:buNone/>
             </a:pPr>
             <a:r>
-              <a:rPr lang="en-US" sz="3400" b="1" dirty="0">
+              <a:rPr lang="en-US" sz="3200" b="1" dirty="0">
                 <a:solidFill>
                   <a:srgbClr val="EAF4F8"/>
                 </a:solidFill>
@@ -4539,20 +4749,20 @@
               </a:rPr>
               <a:t>R$ 69</a:t>
             </a:r>
-            <a:endParaRPr lang="en-US" sz="3400" dirty="0"/>
-          </a:p>
-        </p:txBody>
-      </p:sp>
-      <p:sp>
-        <p:nvSpPr>
-          <p:cNvPr id="22" name="Text 20"/>
-          <p:cNvSpPr/>
-          <p:nvPr/>
-        </p:nvSpPr>
-        <p:spPr>
-          <a:xfrm>
-            <a:off x="6812280" y="3035808"/>
-            <a:ext cx="1874520" cy="274320"/>
+            <a:endParaRPr lang="en-US" sz="3200" dirty="0"/>
+          </a:p>
+        </p:txBody>
+      </p:sp>
+      <p:sp>
+        <p:nvSpPr>
+          <p:cNvPr id="24" name="Text 22"/>
+          <p:cNvSpPr/>
+          <p:nvPr/>
+        </p:nvSpPr>
+        <p:spPr>
+          <a:xfrm>
+            <a:off x="6748272" y="2889504"/>
+            <a:ext cx="1938528" cy="256032"/>
           </a:xfrm>
           <a:prstGeom prst="rect">
             <a:avLst/>
@@ -4568,7 +4778,7 @@
               <a:buNone/>
             </a:pPr>
             <a:r>
-              <a:rPr lang="en-US" sz="1100" dirty="0">
+              <a:rPr lang="en-US" sz="1050" dirty="0">
                 <a:solidFill>
                   <a:srgbClr val="8FA8B5"/>
                 </a:solidFill>
@@ -4578,46 +4788,128 @@
               </a:rPr>
               <a:t>/ produtor / mês</a:t>
             </a:r>
-            <a:endParaRPr lang="en-US" sz="1100" dirty="0"/>
-          </a:p>
-        </p:txBody>
-      </p:sp>
-      <p:sp>
-        <p:nvSpPr>
-          <p:cNvPr id="23" name="Text 21"/>
-          <p:cNvSpPr/>
-          <p:nvPr/>
-        </p:nvSpPr>
-        <p:spPr>
-          <a:xfrm>
-            <a:off x="4754880" y="3657600"/>
-            <a:ext cx="3931920" cy="822960"/>
-          </a:xfrm>
-          <a:prstGeom prst="rect">
-            <a:avLst/>
-          </a:prstGeom>
-          <a:noFill/>
-          <a:ln/>
-        </p:spPr>
-        <p:txBody>
-          <a:bodyPr wrap="square" lIns="0" tIns="0" rIns="0" bIns="0" rtlCol="0" anchor="t"/>
-          <a:lstStyle/>
-          <a:p>
-            <a:pPr indent="0" marL="0">
-              <a:buNone/>
-            </a:pPr>
-            <a:r>
-              <a:rPr lang="en-US" sz="1250" i="1" dirty="0">
-                <a:solidFill>
-                  <a:srgbClr val="8FA8B5"/>
-                </a:solidFill>
-                <a:latin typeface="Calibri" pitchFamily="34" charset="0"/>
-                <a:ea typeface="Calibri" pitchFamily="34" charset="-122"/>
-                <a:cs typeface="Calibri" pitchFamily="34" charset="-120"/>
-              </a:rPr>
-              <a:t>O laticínio assina por produtor e protege a margem: menos descarte e penalidades, bônus garantido.</a:t>
-            </a:r>
-            <a:endParaRPr lang="en-US" sz="1250" dirty="0"/>
+            <a:endParaRPr lang="en-US" sz="1050" dirty="0"/>
+          </a:p>
+        </p:txBody>
+      </p:sp>
+      <p:sp>
+        <p:nvSpPr>
+          <p:cNvPr id="25" name="Text 23"/>
+          <p:cNvSpPr/>
+          <p:nvPr/>
+        </p:nvSpPr>
+        <p:spPr>
+          <a:xfrm>
+            <a:off x="6748272" y="3200400"/>
+            <a:ext cx="1938528" cy="256032"/>
+          </a:xfrm>
+          <a:prstGeom prst="rect">
+            <a:avLst/>
+          </a:prstGeom>
+          <a:noFill/>
+          <a:ln/>
+        </p:spPr>
+        <p:txBody>
+          <a:bodyPr wrap="square" lIns="0" tIns="0" rIns="0" bIns="0" rtlCol="0" anchor="ctr"/>
+          <a:lstStyle/>
+          <a:p>
+            <a:pPr algn="ctr" indent="0" marL="0">
+              <a:buNone/>
+            </a:pPr>
+            <a:r>
+              <a:rPr lang="en-US" sz="1000" b="1" dirty="0">
+                <a:solidFill>
+                  <a:srgbClr val="34D399"/>
+                </a:solidFill>
+                <a:latin typeface="Calibri" pitchFamily="34" charset="0"/>
+                <a:ea typeface="Calibri" pitchFamily="34" charset="-122"/>
+                <a:cs typeface="Calibri" pitchFamily="34" charset="-120"/>
+              </a:rPr>
+              <a:t>Tudo do Básico + COMO agir</a:t>
+            </a:r>
+            <a:endParaRPr lang="en-US" sz="1000" dirty="0"/>
+          </a:p>
+        </p:txBody>
+      </p:sp>
+      <p:sp>
+        <p:nvSpPr>
+          <p:cNvPr id="26" name="Text 24"/>
+          <p:cNvSpPr/>
+          <p:nvPr/>
+        </p:nvSpPr>
+        <p:spPr>
+          <a:xfrm>
+            <a:off x="6858000" y="3456432"/>
+            <a:ext cx="1737360" cy="640080"/>
+          </a:xfrm>
+          <a:prstGeom prst="rect">
+            <a:avLst/>
+          </a:prstGeom>
+          <a:noFill/>
+          <a:ln/>
+        </p:spPr>
+        <p:txBody>
+          <a:bodyPr wrap="square" lIns="0" tIns="0" rIns="0" bIns="0" rtlCol="0" anchor="ctr"/>
+          <a:lstStyle/>
+          <a:p>
+            <a:pPr algn="ctr" indent="0" marL="0">
+              <a:lnSpc>
+                <a:spcPct val="105000"/>
+              </a:lnSpc>
+              <a:buNone/>
+            </a:pPr>
+            <a:r>
+              <a:rPr lang="en-US" sz="950" dirty="0">
+                <a:solidFill>
+                  <a:srgbClr val="EAF4F8"/>
+                </a:solidFill>
+                <a:latin typeface="Calibri" pitchFamily="34" charset="0"/>
+                <a:ea typeface="Calibri" pitchFamily="34" charset="-122"/>
+                <a:cs typeface="Calibri" pitchFamily="34" charset="-120"/>
+              </a:rPr>
+              <a:t>Perfil do produtor</a:t>
+            </a:r>
+            <a:endParaRPr lang="en-US" sz="950" dirty="0"/>
+          </a:p>
+          <a:p>
+            <a:pPr algn="ctr" indent="0" marL="0">
+              <a:lnSpc>
+                <a:spcPct val="105000"/>
+              </a:lnSpc>
+              <a:buNone/>
+            </a:pPr>
+            <a:r>
+              <a:rPr lang="en-US" sz="950" dirty="0">
+                <a:solidFill>
+                  <a:srgbClr val="EAF4F8"/>
+                </a:solidFill>
+                <a:latin typeface="Calibri" pitchFamily="34" charset="0"/>
+                <a:ea typeface="Calibri" pitchFamily="34" charset="-122"/>
+                <a:cs typeface="Calibri" pitchFamily="34" charset="-120"/>
+              </a:rPr>
+              <a:t>Impacto em R$ + Plano</a:t>
+            </a:r>
+            <a:endParaRPr lang="en-US" sz="950" dirty="0"/>
+          </a:p>
+          <a:p>
+            <a:pPr algn="ctr" indent="0" marL="0">
+              <a:lnSpc>
+                <a:spcPct val="105000"/>
+              </a:lnSpc>
+              <a:buNone/>
+            </a:pPr>
+            <a:r>
+              <a:rPr lang="en-US" sz="950" dirty="0">
+                <a:solidFill>
+                  <a:srgbClr val="EAF4F8"/>
+                </a:solidFill>
+                <a:latin typeface="Calibri" pitchFamily="34" charset="0"/>
+                <a:ea typeface="Calibri" pitchFamily="34" charset="-122"/>
+                <a:cs typeface="Calibri" pitchFamily="34" charset="-120"/>
+              </a:rPr>
+              <a:t>API + suporte</a:t>
+            </a:r>
+            <a:endParaRPr lang="en-US" sz="950" dirty="0"/>
           </a:p>
         </p:txBody>
       </p:sp>
@@ -5146,8 +5438,8 @@
         </p:nvSpPr>
         <p:spPr>
           <a:xfrm>
-            <a:off x="457200" y="4251960"/>
-            <a:ext cx="8229600" cy="320040"/>
+            <a:off x="457200" y="4160520"/>
+            <a:ext cx="8229600" cy="274320"/>
           </a:xfrm>
           <a:prstGeom prst="rect">
             <a:avLst/>
@@ -5163,7 +5455,7 @@
               <a:buNone/>
             </a:pPr>
             <a:r>
-              <a:rPr lang="en-US" sz="1100" dirty="0">
+              <a:rPr lang="en-US" sz="950" dirty="0">
                 <a:solidFill>
                   <a:srgbClr val="8FA8B5"/>
                 </a:solidFill>
@@ -5171,9 +5463,48 @@
                 <a:ea typeface="Calibri" pitchFamily="34" charset="-122"/>
                 <a:cs typeface="Calibri" pitchFamily="34" charset="-120"/>
               </a:rPr>
-              <a:t>Benchmarks: Embrapa Gado de Leite · MAPA IN 77/2018 · FAO.</a:t>
-            </a:r>
-            <a:endParaRPr lang="en-US" sz="1100" dirty="0"/>
+              <a:t>Base (produtor médio ~400 L/dia): bônus protegido ~R$ 960 + descarte evitado ~R$ 294 (4 L/dia). CO₂: ~73 mil L/ano evitados × 2,5 kg CO₂-eq/L.</a:t>
+            </a:r>
+            <a:endParaRPr lang="en-US" sz="950" dirty="0"/>
+          </a:p>
+        </p:txBody>
+      </p:sp>
+      <p:sp>
+        <p:nvSpPr>
+          <p:cNvPr id="15" name="Text 13"/>
+          <p:cNvSpPr/>
+          <p:nvPr/>
+        </p:nvSpPr>
+        <p:spPr>
+          <a:xfrm>
+            <a:off x="457200" y="4416552"/>
+            <a:ext cx="8229600" cy="274320"/>
+          </a:xfrm>
+          <a:prstGeom prst="rect">
+            <a:avLst/>
+          </a:prstGeom>
+          <a:noFill/>
+          <a:ln/>
+        </p:spPr>
+        <p:txBody>
+          <a:bodyPr wrap="square" lIns="0" tIns="0" rIns="0" bIns="0" rtlCol="0" anchor="ctr"/>
+          <a:lstStyle/>
+          <a:p>
+            <a:pPr indent="0" marL="0">
+              <a:buNone/>
+            </a:pPr>
+            <a:r>
+              <a:rPr lang="en-US" sz="950" dirty="0">
+                <a:solidFill>
+                  <a:srgbClr val="8FA8B5"/>
+                </a:solidFill>
+                <a:latin typeface="Calibri" pitchFamily="34" charset="0"/>
+                <a:ea typeface="Calibri" pitchFamily="34" charset="-122"/>
+                <a:cs typeface="Calibri" pitchFamily="34" charset="-120"/>
+              </a:rPr>
+              <a:t>Benchmarks: Embrapa · MAPA IN 77/2018 · FAO (2010). Memória de cálculo detalhada no plano de negócio.</a:t>
+            </a:r>
+            <a:endParaRPr lang="en-US" sz="950" dirty="0"/>
           </a:p>
         </p:txBody>
       </p:sp>
@@ -5262,7 +5593,7 @@
                 <a:ea typeface="Calibri" pitchFamily="34" charset="-122"/>
                 <a:cs typeface="Calibri" pitchFamily="34" charset="-120"/>
               </a:rPr>
-              <a:t>ROADMAP &amp; EQUIPE</a:t>
+              <a:t>ROADMAP</a:t>
             </a:r>
             <a:endParaRPr lang="en-US" sz="1150" dirty="0"/>
           </a:p>
@@ -5293,7 +5624,7 @@
               <a:buNone/>
             </a:pPr>
             <a:r>
-              <a:rPr lang="en-US" sz="2900" b="1" dirty="0">
+              <a:rPr lang="en-US" sz="3000" b="1" dirty="0">
                 <a:solidFill>
                   <a:srgbClr val="FFFFFF"/>
                 </a:solidFill>
@@ -5301,9 +5632,9 @@
                 <a:ea typeface="Calibri" pitchFamily="34" charset="-122"/>
                 <a:cs typeface="Calibri" pitchFamily="34" charset="-120"/>
               </a:rPr>
-              <a:t>Onde chegamos — e quem somos.</a:t>
-            </a:r>
-            <a:endParaRPr lang="en-US" sz="2900" dirty="0"/>
+              <a:t>Onde chegamos — e o próximo passo.</a:t>
+            </a:r>
+            <a:endParaRPr lang="en-US" sz="3000" dirty="0"/>
           </a:p>
         </p:txBody>
       </p:sp>
@@ -5315,12 +5646,12 @@
         </p:nvSpPr>
         <p:spPr>
           <a:xfrm>
-            <a:off x="457200" y="1627632"/>
-            <a:ext cx="1993392" cy="1078992"/>
+            <a:off x="457200" y="1874520"/>
+            <a:ext cx="1993392" cy="2103120"/>
           </a:xfrm>
           <a:prstGeom prst="roundRect">
             <a:avLst>
-              <a:gd name="adj" fmla="val 7627"/>
+              <a:gd name="adj" fmla="val 4128"/>
             </a:avLst>
           </a:prstGeom>
           <a:solidFill>
@@ -5349,8 +5680,8 @@
         </p:nvSpPr>
         <p:spPr>
           <a:xfrm>
-            <a:off x="457200" y="1737360"/>
-            <a:ext cx="1993392" cy="365760"/>
+            <a:off x="457200" y="2057400"/>
+            <a:ext cx="1993392" cy="457200"/>
           </a:xfrm>
           <a:prstGeom prst="rect">
             <a:avLst/>
@@ -5366,14 +5697,14 @@
               <a:buNone/>
             </a:pPr>
             <a:r>
-              <a:rPr lang="en-US" sz="1700" dirty="0">
+              <a:rPr lang="en-US" sz="2200" dirty="0">
                 <a:solidFill>
                   <a:srgbClr val="000000"/>
                 </a:solidFill>
               </a:rPr>
               <a:t>✅</a:t>
             </a:r>
-            <a:endParaRPr lang="en-US" sz="1700" dirty="0"/>
+            <a:endParaRPr lang="en-US" sz="2200" dirty="0"/>
           </a:p>
         </p:txBody>
       </p:sp>
@@ -5385,24 +5716,24 @@
         </p:nvSpPr>
         <p:spPr>
           <a:xfrm>
-            <a:off x="548640" y="2121408"/>
-            <a:ext cx="1810512" cy="320040"/>
-          </a:xfrm>
-          <a:prstGeom prst="rect">
-            <a:avLst/>
-          </a:prstGeom>
-          <a:noFill/>
-          <a:ln/>
-        </p:spPr>
-        <p:txBody>
-          <a:bodyPr wrap="square" lIns="0" tIns="0" rIns="0" bIns="0" rtlCol="0" anchor="ctr"/>
+            <a:off x="548640" y="2606040"/>
+            <a:ext cx="1810512" cy="640080"/>
+          </a:xfrm>
+          <a:prstGeom prst="rect">
+            <a:avLst/>
+          </a:prstGeom>
+          <a:noFill/>
+          <a:ln/>
+        </p:spPr>
+        <p:txBody>
+          <a:bodyPr wrap="square" lIns="0" tIns="0" rIns="0" bIns="0" rtlCol="0" anchor="t"/>
           <a:lstStyle/>
           <a:p>
             <a:pPr algn="ctr" indent="0" marL="0">
               <a:buNone/>
             </a:pPr>
             <a:r>
-              <a:rPr lang="en-US" sz="1350" b="1" dirty="0">
+              <a:rPr lang="en-US" sz="1500" b="1" dirty="0">
                 <a:solidFill>
                   <a:srgbClr val="34D399"/>
                 </a:solidFill>
@@ -5412,7 +5743,7 @@
               </a:rPr>
               <a:t>Score + Radar</a:t>
             </a:r>
-            <a:endParaRPr lang="en-US" sz="1350" dirty="0"/>
+            <a:endParaRPr lang="en-US" sz="1500" dirty="0"/>
           </a:p>
         </p:txBody>
       </p:sp>
@@ -5424,24 +5755,24 @@
         </p:nvSpPr>
         <p:spPr>
           <a:xfrm>
-            <a:off x="548640" y="2395728"/>
-            <a:ext cx="1810512" cy="274320"/>
-          </a:xfrm>
-          <a:prstGeom prst="rect">
-            <a:avLst/>
-          </a:prstGeom>
-          <a:noFill/>
-          <a:ln/>
-        </p:spPr>
-        <p:txBody>
-          <a:bodyPr wrap="square" lIns="0" tIns="0" rIns="0" bIns="0" rtlCol="0" anchor="ctr"/>
+            <a:off x="548640" y="3200400"/>
+            <a:ext cx="1810512" cy="640080"/>
+          </a:xfrm>
+          <a:prstGeom prst="rect">
+            <a:avLst/>
+          </a:prstGeom>
+          <a:noFill/>
+          <a:ln/>
+        </p:spPr>
+        <p:txBody>
+          <a:bodyPr wrap="square" lIns="0" tIns="0" rIns="0" bIns="0" rtlCol="0" anchor="t"/>
           <a:lstStyle/>
           <a:p>
             <a:pPr algn="ctr" indent="0" marL="0">
               <a:buNone/>
             </a:pPr>
             <a:r>
-              <a:rPr lang="en-US" sz="1100" dirty="0">
+              <a:rPr lang="en-US" sz="1200" dirty="0">
                 <a:solidFill>
                   <a:srgbClr val="8FA8B5"/>
                 </a:solidFill>
@@ -5449,9 +5780,9 @@
                 <a:ea typeface="Calibri" pitchFamily="34" charset="-122"/>
                 <a:cs typeface="Calibri" pitchFamily="34" charset="-120"/>
               </a:rPr>
-              <a:t>No ar</a:t>
-            </a:r>
-            <a:endParaRPr lang="en-US" sz="1100" dirty="0"/>
+              <a:t>No ar (produção)</a:t>
+            </a:r>
+            <a:endParaRPr lang="en-US" sz="1200" dirty="0"/>
           </a:p>
         </p:txBody>
       </p:sp>
@@ -5463,12 +5794,12 @@
         </p:nvSpPr>
         <p:spPr>
           <a:xfrm>
-            <a:off x="2569464" y="1627632"/>
-            <a:ext cx="1993392" cy="1078992"/>
+            <a:off x="2569464" y="1874520"/>
+            <a:ext cx="1993392" cy="2103120"/>
           </a:xfrm>
           <a:prstGeom prst="roundRect">
             <a:avLst>
-              <a:gd name="adj" fmla="val 7627"/>
+              <a:gd name="adj" fmla="val 4128"/>
             </a:avLst>
           </a:prstGeom>
           <a:solidFill>
@@ -5497,8 +5828,8 @@
         </p:nvSpPr>
         <p:spPr>
           <a:xfrm>
-            <a:off x="2569464" y="1737360"/>
-            <a:ext cx="1993392" cy="365760"/>
+            <a:off x="2569464" y="2057400"/>
+            <a:ext cx="1993392" cy="457200"/>
           </a:xfrm>
           <a:prstGeom prst="rect">
             <a:avLst/>
@@ -5514,14 +5845,14 @@
               <a:buNone/>
             </a:pPr>
             <a:r>
-              <a:rPr lang="en-US" sz="1700" dirty="0">
+              <a:rPr lang="en-US" sz="2200" dirty="0">
                 <a:solidFill>
                   <a:srgbClr val="000000"/>
                 </a:solidFill>
               </a:rPr>
               <a:t>✅</a:t>
             </a:r>
-            <a:endParaRPr lang="en-US" sz="1700" dirty="0"/>
+            <a:endParaRPr lang="en-US" sz="2200" dirty="0"/>
           </a:p>
         </p:txBody>
       </p:sp>
@@ -5533,24 +5864,24 @@
         </p:nvSpPr>
         <p:spPr>
           <a:xfrm>
-            <a:off x="2660904" y="2121408"/>
-            <a:ext cx="1810512" cy="320040"/>
-          </a:xfrm>
-          <a:prstGeom prst="rect">
-            <a:avLst/>
-          </a:prstGeom>
-          <a:noFill/>
-          <a:ln/>
-        </p:spPr>
-        <p:txBody>
-          <a:bodyPr wrap="square" lIns="0" tIns="0" rIns="0" bIns="0" rtlCol="0" anchor="ctr"/>
+            <a:off x="2660904" y="2606040"/>
+            <a:ext cx="1810512" cy="640080"/>
+          </a:xfrm>
+          <a:prstGeom prst="rect">
+            <a:avLst/>
+          </a:prstGeom>
+          <a:noFill/>
+          <a:ln/>
+        </p:spPr>
+        <p:txBody>
+          <a:bodyPr wrap="square" lIns="0" tIns="0" rIns="0" bIns="0" rtlCol="0" anchor="t"/>
           <a:lstStyle/>
           <a:p>
             <a:pPr algn="ctr" indent="0" marL="0">
               <a:buNone/>
             </a:pPr>
             <a:r>
-              <a:rPr lang="en-US" sz="1350" b="1" dirty="0">
+              <a:rPr lang="en-US" sz="1500" b="1" dirty="0">
                 <a:solidFill>
                   <a:srgbClr val="34D399"/>
                 </a:solidFill>
@@ -5558,9 +5889,9 @@
                 <a:ea typeface="Calibri" pitchFamily="34" charset="-122"/>
                 <a:cs typeface="Calibri" pitchFamily="34" charset="-120"/>
               </a:rPr>
-              <a:t>Perfil</a:t>
-            </a:r>
-            <a:endParaRPr lang="en-US" sz="1350" dirty="0"/>
+              <a:t>Perfil do Produtor</a:t>
+            </a:r>
+            <a:endParaRPr lang="en-US" sz="1500" dirty="0"/>
           </a:p>
         </p:txBody>
       </p:sp>
@@ -5572,24 +5903,24 @@
         </p:nvSpPr>
         <p:spPr>
           <a:xfrm>
-            <a:off x="2660904" y="2395728"/>
-            <a:ext cx="1810512" cy="274320"/>
-          </a:xfrm>
-          <a:prstGeom prst="rect">
-            <a:avLst/>
-          </a:prstGeom>
-          <a:noFill/>
-          <a:ln/>
-        </p:spPr>
-        <p:txBody>
-          <a:bodyPr wrap="square" lIns="0" tIns="0" rIns="0" bIns="0" rtlCol="0" anchor="ctr"/>
+            <a:off x="2660904" y="3200400"/>
+            <a:ext cx="1810512" cy="640080"/>
+          </a:xfrm>
+          <a:prstGeom prst="rect">
+            <a:avLst/>
+          </a:prstGeom>
+          <a:noFill/>
+          <a:ln/>
+        </p:spPr>
+        <p:txBody>
+          <a:bodyPr wrap="square" lIns="0" tIns="0" rIns="0" bIns="0" rtlCol="0" anchor="t"/>
           <a:lstStyle/>
           <a:p>
             <a:pPr algn="ctr" indent="0" marL="0">
               <a:buNone/>
             </a:pPr>
             <a:r>
-              <a:rPr lang="en-US" sz="1100" dirty="0">
+              <a:rPr lang="en-US" sz="1200" dirty="0">
                 <a:solidFill>
                   <a:srgbClr val="8FA8B5"/>
                 </a:solidFill>
@@ -5597,9 +5928,9 @@
                 <a:ea typeface="Calibri" pitchFamily="34" charset="-122"/>
                 <a:cs typeface="Calibri" pitchFamily="34" charset="-120"/>
               </a:rPr>
-              <a:t>Validado</a:t>
-            </a:r>
-            <a:endParaRPr lang="en-US" sz="1100" dirty="0"/>
+              <a:t>Validado em protótipo</a:t>
+            </a:r>
+            <a:endParaRPr lang="en-US" sz="1200" dirty="0"/>
           </a:p>
         </p:txBody>
       </p:sp>
@@ -5611,12 +5942,12 @@
         </p:nvSpPr>
         <p:spPr>
           <a:xfrm>
-            <a:off x="4681728" y="1627632"/>
-            <a:ext cx="1993392" cy="1078992"/>
+            <a:off x="4681728" y="1874520"/>
+            <a:ext cx="1993392" cy="2103120"/>
           </a:xfrm>
           <a:prstGeom prst="roundRect">
             <a:avLst>
-              <a:gd name="adj" fmla="val 7627"/>
+              <a:gd name="adj" fmla="val 4128"/>
             </a:avLst>
           </a:prstGeom>
           <a:solidFill>
@@ -5645,8 +5976,8 @@
         </p:nvSpPr>
         <p:spPr>
           <a:xfrm>
-            <a:off x="4681728" y="1737360"/>
-            <a:ext cx="1993392" cy="365760"/>
+            <a:off x="4681728" y="2057400"/>
+            <a:ext cx="1993392" cy="457200"/>
           </a:xfrm>
           <a:prstGeom prst="rect">
             <a:avLst/>
@@ -5662,14 +5993,14 @@
               <a:buNone/>
             </a:pPr>
             <a:r>
-              <a:rPr lang="en-US" sz="1700" dirty="0">
+              <a:rPr lang="en-US" sz="2200" dirty="0">
                 <a:solidFill>
                   <a:srgbClr val="000000"/>
                 </a:solidFill>
               </a:rPr>
               <a:t>🔄</a:t>
             </a:r>
-            <a:endParaRPr lang="en-US" sz="1700" dirty="0"/>
+            <a:endParaRPr lang="en-US" sz="2200" dirty="0"/>
           </a:p>
         </p:txBody>
       </p:sp>
@@ -5681,24 +6012,24 @@
         </p:nvSpPr>
         <p:spPr>
           <a:xfrm>
-            <a:off x="4773168" y="2121408"/>
-            <a:ext cx="1810512" cy="320040"/>
-          </a:xfrm>
-          <a:prstGeom prst="rect">
-            <a:avLst/>
-          </a:prstGeom>
-          <a:noFill/>
-          <a:ln/>
-        </p:spPr>
-        <p:txBody>
-          <a:bodyPr wrap="square" lIns="0" tIns="0" rIns="0" bIns="0" rtlCol="0" anchor="ctr"/>
+            <a:off x="4773168" y="2606040"/>
+            <a:ext cx="1810512" cy="640080"/>
+          </a:xfrm>
+          <a:prstGeom prst="rect">
+            <a:avLst/>
+          </a:prstGeom>
+          <a:noFill/>
+          <a:ln/>
+        </p:spPr>
+        <p:txBody>
+          <a:bodyPr wrap="square" lIns="0" tIns="0" rIns="0" bIns="0" rtlCol="0" anchor="t"/>
           <a:lstStyle/>
           <a:p>
             <a:pPr algn="ctr" indent="0" marL="0">
               <a:buNone/>
             </a:pPr>
             <a:r>
-              <a:rPr lang="en-US" sz="1350" b="1" dirty="0">
+              <a:rPr lang="en-US" sz="1500" b="1" dirty="0">
                 <a:solidFill>
                   <a:srgbClr val="F59E0B"/>
                 </a:solidFill>
@@ -5708,7 +6039,7 @@
               </a:rPr>
               <a:t>Piloto pago</a:t>
             </a:r>
-            <a:endParaRPr lang="en-US" sz="1350" dirty="0"/>
+            <a:endParaRPr lang="en-US" sz="1500" dirty="0"/>
           </a:p>
         </p:txBody>
       </p:sp>
@@ -5720,24 +6051,24 @@
         </p:nvSpPr>
         <p:spPr>
           <a:xfrm>
-            <a:off x="4773168" y="2395728"/>
-            <a:ext cx="1810512" cy="274320"/>
-          </a:xfrm>
-          <a:prstGeom prst="rect">
-            <a:avLst/>
-          </a:prstGeom>
-          <a:noFill/>
-          <a:ln/>
-        </p:spPr>
-        <p:txBody>
-          <a:bodyPr wrap="square" lIns="0" tIns="0" rIns="0" bIns="0" rtlCol="0" anchor="ctr"/>
+            <a:off x="4773168" y="3200400"/>
+            <a:ext cx="1810512" cy="640080"/>
+          </a:xfrm>
+          <a:prstGeom prst="rect">
+            <a:avLst/>
+          </a:prstGeom>
+          <a:noFill/>
+          <a:ln/>
+        </p:spPr>
+        <p:txBody>
+          <a:bodyPr wrap="square" lIns="0" tIns="0" rIns="0" bIns="0" rtlCol="0" anchor="t"/>
           <a:lstStyle/>
           <a:p>
             <a:pPr algn="ctr" indent="0" marL="0">
               <a:buNone/>
             </a:pPr>
             <a:r>
-              <a:rPr lang="en-US" sz="1100" dirty="0">
+              <a:rPr lang="en-US" sz="1200" dirty="0">
                 <a:solidFill>
                   <a:srgbClr val="8FA8B5"/>
                 </a:solidFill>
@@ -5745,9 +6076,9 @@
                 <a:ea typeface="Calibri" pitchFamily="34" charset="-122"/>
                 <a:cs typeface="Calibri" pitchFamily="34" charset="-120"/>
               </a:rPr>
-              <a:t>Sul Goiano</a:t>
-            </a:r>
-            <a:endParaRPr lang="en-US" sz="1100" dirty="0"/>
+              <a:t>Sul Goiano · dados reais</a:t>
+            </a:r>
+            <a:endParaRPr lang="en-US" sz="1200" dirty="0"/>
           </a:p>
         </p:txBody>
       </p:sp>
@@ -5759,12 +6090,12 @@
         </p:nvSpPr>
         <p:spPr>
           <a:xfrm>
-            <a:off x="6793992" y="1627632"/>
-            <a:ext cx="1993392" cy="1078992"/>
+            <a:off x="6793992" y="1874520"/>
+            <a:ext cx="1993392" cy="2103120"/>
           </a:xfrm>
           <a:prstGeom prst="roundRect">
             <a:avLst>
-              <a:gd name="adj" fmla="val 7627"/>
+              <a:gd name="adj" fmla="val 4128"/>
             </a:avLst>
           </a:prstGeom>
           <a:solidFill>
@@ -5793,8 +6124,8 @@
         </p:nvSpPr>
         <p:spPr>
           <a:xfrm>
-            <a:off x="6793992" y="1737360"/>
-            <a:ext cx="1993392" cy="365760"/>
+            <a:off x="6793992" y="2057400"/>
+            <a:ext cx="1993392" cy="457200"/>
           </a:xfrm>
           <a:prstGeom prst="rect">
             <a:avLst/>
@@ -5810,14 +6141,14 @@
               <a:buNone/>
             </a:pPr>
             <a:r>
-              <a:rPr lang="en-US" sz="1700" dirty="0">
+              <a:rPr lang="en-US" sz="2200" dirty="0">
                 <a:solidFill>
                   <a:srgbClr val="000000"/>
                 </a:solidFill>
               </a:rPr>
               <a:t>⬜</a:t>
             </a:r>
-            <a:endParaRPr lang="en-US" sz="1700" dirty="0"/>
+            <a:endParaRPr lang="en-US" sz="2200" dirty="0"/>
           </a:p>
         </p:txBody>
       </p:sp>
@@ -5829,24 +6160,24 @@
         </p:nvSpPr>
         <p:spPr>
           <a:xfrm>
-            <a:off x="6885432" y="2121408"/>
-            <a:ext cx="1810512" cy="320040"/>
-          </a:xfrm>
-          <a:prstGeom prst="rect">
-            <a:avLst/>
-          </a:prstGeom>
-          <a:noFill/>
-          <a:ln/>
-        </p:spPr>
-        <p:txBody>
-          <a:bodyPr wrap="square" lIns="0" tIns="0" rIns="0" bIns="0" rtlCol="0" anchor="ctr"/>
+            <a:off x="6885432" y="2606040"/>
+            <a:ext cx="1810512" cy="640080"/>
+          </a:xfrm>
+          <a:prstGeom prst="rect">
+            <a:avLst/>
+          </a:prstGeom>
+          <a:noFill/>
+          <a:ln/>
+        </p:spPr>
+        <p:txBody>
+          <a:bodyPr wrap="square" lIns="0" tIns="0" rIns="0" bIns="0" rtlCol="0" anchor="t"/>
           <a:lstStyle/>
           <a:p>
             <a:pPr algn="ctr" indent="0" marL="0">
               <a:buNone/>
             </a:pPr>
             <a:r>
-              <a:rPr lang="en-US" sz="1350" b="1" dirty="0">
+              <a:rPr lang="en-US" sz="1500" b="1" dirty="0">
                 <a:solidFill>
                   <a:srgbClr val="8FA8B5"/>
                 </a:solidFill>
@@ -5856,7 +6187,7 @@
               </a:rPr>
               <a:t>IoT / Edge</a:t>
             </a:r>
-            <a:endParaRPr lang="en-US" sz="1350" dirty="0"/>
+            <a:endParaRPr lang="en-US" sz="1500" dirty="0"/>
           </a:p>
         </p:txBody>
       </p:sp>
@@ -5868,24 +6199,24 @@
         </p:nvSpPr>
         <p:spPr>
           <a:xfrm>
-            <a:off x="6885432" y="2395728"/>
-            <a:ext cx="1810512" cy="274320"/>
-          </a:xfrm>
-          <a:prstGeom prst="rect">
-            <a:avLst/>
-          </a:prstGeom>
-          <a:noFill/>
-          <a:ln/>
-        </p:spPr>
-        <p:txBody>
-          <a:bodyPr wrap="square" lIns="0" tIns="0" rIns="0" bIns="0" rtlCol="0" anchor="ctr"/>
+            <a:off x="6885432" y="3200400"/>
+            <a:ext cx="1810512" cy="640080"/>
+          </a:xfrm>
+          <a:prstGeom prst="rect">
+            <a:avLst/>
+          </a:prstGeom>
+          <a:noFill/>
+          <a:ln/>
+        </p:spPr>
+        <p:txBody>
+          <a:bodyPr wrap="square" lIns="0" tIns="0" rIns="0" bIns="0" rtlCol="0" anchor="t"/>
           <a:lstStyle/>
           <a:p>
             <a:pPr algn="ctr" indent="0" marL="0">
               <a:buNone/>
             </a:pPr>
             <a:r>
-              <a:rPr lang="en-US" sz="1100" dirty="0">
+              <a:rPr lang="en-US" sz="1200" dirty="0">
                 <a:solidFill>
                   <a:srgbClr val="8FA8B5"/>
                 </a:solidFill>
@@ -5893,889 +6224,9 @@
                 <a:ea typeface="Calibri" pitchFamily="34" charset="-122"/>
                 <a:cs typeface="Calibri" pitchFamily="34" charset="-120"/>
               </a:rPr>
-              <a:t>Sensores</a:t>
-            </a:r>
-            <a:endParaRPr lang="en-US" sz="1100" dirty="0"/>
-          </a:p>
-        </p:txBody>
-      </p:sp>
-      <p:sp>
-        <p:nvSpPr>
-          <p:cNvPr id="21" name="Shape 19"/>
-          <p:cNvSpPr/>
-          <p:nvPr/>
-        </p:nvSpPr>
-        <p:spPr>
-          <a:xfrm>
-            <a:off x="457200" y="2926080"/>
-            <a:ext cx="1673352" cy="1508760"/>
-          </a:xfrm>
-          <a:prstGeom prst="roundRect">
-            <a:avLst>
-              <a:gd name="adj" fmla="val 5455"/>
-            </a:avLst>
-          </a:prstGeom>
-          <a:solidFill>
-            <a:srgbClr val="13313F"/>
-          </a:solidFill>
-          <a:ln w="12700">
-            <a:solidFill>
-              <a:srgbClr val="21485A"/>
-            </a:solidFill>
-            <a:prstDash val="solid"/>
-          </a:ln>
-          <a:effectLst>
-            <a:outerShdw sx="100000" sy="100000" kx="0" ky="0" algn="bl" rotWithShape="0" blurRad="88900" dist="38100" dir="5400000">
-              <a:srgbClr val="000000">
-                <a:alpha val="28000"/>
-              </a:srgbClr>
-            </a:outerShdw>
-          </a:effectLst>
-        </p:spPr>
-      </p:sp>
-      <p:sp>
-        <p:nvSpPr>
-          <p:cNvPr id="22" name="Shape 20"/>
-          <p:cNvSpPr/>
-          <p:nvPr/>
-        </p:nvSpPr>
-        <p:spPr>
-          <a:xfrm>
-            <a:off x="1056132" y="3108960"/>
-            <a:ext cx="475488" cy="475488"/>
-          </a:xfrm>
-          <a:prstGeom prst="ellipse">
-            <a:avLst/>
-          </a:prstGeom>
-          <a:solidFill>
-            <a:srgbClr val="0F2A38"/>
-          </a:solidFill>
-          <a:ln w="19050">
-            <a:solidFill>
-              <a:srgbClr val="19D3E6"/>
-            </a:solidFill>
-            <a:prstDash val="solid"/>
-          </a:ln>
-        </p:spPr>
-      </p:sp>
-      <p:sp>
-        <p:nvSpPr>
-          <p:cNvPr id="23" name="Text 21"/>
-          <p:cNvSpPr/>
-          <p:nvPr/>
-        </p:nvSpPr>
-        <p:spPr>
-          <a:xfrm>
-            <a:off x="1056132" y="3108960"/>
-            <a:ext cx="475488" cy="475488"/>
-          </a:xfrm>
-          <a:prstGeom prst="rect">
-            <a:avLst/>
-          </a:prstGeom>
-          <a:noFill/>
-          <a:ln/>
-        </p:spPr>
-        <p:txBody>
-          <a:bodyPr wrap="square" lIns="0" tIns="0" rIns="0" bIns="0" rtlCol="0" anchor="ctr"/>
-          <a:lstStyle/>
-          <a:p>
-            <a:pPr algn="ctr" indent="0" marL="0">
-              <a:buNone/>
-            </a:pPr>
-            <a:r>
-              <a:rPr lang="en-US" sz="1500" b="1" dirty="0">
-                <a:solidFill>
-                  <a:srgbClr val="19D3E6"/>
-                </a:solidFill>
-                <a:latin typeface="Calibri" pitchFamily="34" charset="0"/>
-                <a:ea typeface="Calibri" pitchFamily="34" charset="-122"/>
-                <a:cs typeface="Calibri" pitchFamily="34" charset="-120"/>
-              </a:rPr>
-              <a:t>FP</a:t>
-            </a:r>
-            <a:endParaRPr lang="en-US" sz="1500" dirty="0"/>
-          </a:p>
-        </p:txBody>
-      </p:sp>
-      <p:sp>
-        <p:nvSpPr>
-          <p:cNvPr id="24" name="Text 22"/>
-          <p:cNvSpPr/>
-          <p:nvPr/>
-        </p:nvSpPr>
-        <p:spPr>
-          <a:xfrm>
-            <a:off x="512064" y="3657600"/>
-            <a:ext cx="1563624" cy="411480"/>
-          </a:xfrm>
-          <a:prstGeom prst="rect">
-            <a:avLst/>
-          </a:prstGeom>
-          <a:noFill/>
-          <a:ln/>
-        </p:spPr>
-        <p:txBody>
-          <a:bodyPr wrap="square" lIns="0" tIns="0" rIns="0" bIns="0" rtlCol="0" anchor="t"/>
-          <a:lstStyle/>
-          <a:p>
-            <a:pPr algn="ctr" indent="0" marL="0">
-              <a:buNone/>
-            </a:pPr>
-            <a:r>
-              <a:rPr lang="en-US" sz="1250" b="1" dirty="0">
-                <a:solidFill>
-                  <a:srgbClr val="EAF4F8"/>
-                </a:solidFill>
-                <a:latin typeface="Calibri" pitchFamily="34" charset="0"/>
-                <a:ea typeface="Calibri" pitchFamily="34" charset="-122"/>
-                <a:cs typeface="Calibri" pitchFamily="34" charset="-120"/>
-              </a:rPr>
-              <a:t>Fagner Pinho</a:t>
-            </a:r>
-            <a:endParaRPr lang="en-US" sz="1250" dirty="0"/>
-          </a:p>
-        </p:txBody>
-      </p:sp>
-      <p:sp>
-        <p:nvSpPr>
-          <p:cNvPr id="25" name="Text 23"/>
-          <p:cNvSpPr/>
-          <p:nvPr/>
-        </p:nvSpPr>
-        <p:spPr>
-          <a:xfrm>
-            <a:off x="512064" y="4059936"/>
-            <a:ext cx="1563624" cy="320040"/>
-          </a:xfrm>
-          <a:prstGeom prst="rect">
-            <a:avLst/>
-          </a:prstGeom>
-          <a:noFill/>
-          <a:ln/>
-        </p:spPr>
-        <p:txBody>
-          <a:bodyPr wrap="square" lIns="0" tIns="0" rIns="0" bIns="0" rtlCol="0" anchor="t"/>
-          <a:lstStyle/>
-          <a:p>
-            <a:pPr algn="ctr" indent="0" marL="0">
-              <a:buNone/>
-            </a:pPr>
-            <a:r>
-              <a:rPr lang="en-US" sz="1000" dirty="0">
-                <a:solidFill>
-                  <a:srgbClr val="8FA8B5"/>
-                </a:solidFill>
-                <a:latin typeface="Calibri" pitchFamily="34" charset="0"/>
-                <a:ea typeface="Calibri" pitchFamily="34" charset="-122"/>
-                <a:cs typeface="Calibri" pitchFamily="34" charset="-120"/>
-              </a:rPr>
-              <a:t>Negócio / Produto</a:t>
-            </a:r>
-            <a:endParaRPr lang="en-US" sz="1000" dirty="0"/>
-          </a:p>
-        </p:txBody>
-      </p:sp>
-      <p:sp>
-        <p:nvSpPr>
-          <p:cNvPr id="26" name="Shape 24"/>
-          <p:cNvSpPr/>
-          <p:nvPr/>
-        </p:nvSpPr>
-        <p:spPr>
-          <a:xfrm>
-            <a:off x="2167128" y="2926080"/>
-            <a:ext cx="1673352" cy="1508760"/>
-          </a:xfrm>
-          <a:prstGeom prst="roundRect">
-            <a:avLst>
-              <a:gd name="adj" fmla="val 5455"/>
-            </a:avLst>
-          </a:prstGeom>
-          <a:solidFill>
-            <a:srgbClr val="13313F"/>
-          </a:solidFill>
-          <a:ln w="12700">
-            <a:solidFill>
-              <a:srgbClr val="21485A"/>
-            </a:solidFill>
-            <a:prstDash val="solid"/>
-          </a:ln>
-          <a:effectLst>
-            <a:outerShdw sx="100000" sy="100000" kx="0" ky="0" algn="bl" rotWithShape="0" blurRad="88900" dist="38100" dir="5400000">
-              <a:srgbClr val="000000">
-                <a:alpha val="28000"/>
-              </a:srgbClr>
-            </a:outerShdw>
-          </a:effectLst>
-        </p:spPr>
-      </p:sp>
-      <p:sp>
-        <p:nvSpPr>
-          <p:cNvPr id="27" name="Shape 25"/>
-          <p:cNvSpPr/>
-          <p:nvPr/>
-        </p:nvSpPr>
-        <p:spPr>
-          <a:xfrm>
-            <a:off x="2766060" y="3108960"/>
-            <a:ext cx="475488" cy="475488"/>
-          </a:xfrm>
-          <a:prstGeom prst="ellipse">
-            <a:avLst/>
-          </a:prstGeom>
-          <a:solidFill>
-            <a:srgbClr val="0F2A38"/>
-          </a:solidFill>
-          <a:ln w="19050">
-            <a:solidFill>
-              <a:srgbClr val="19D3E6"/>
-            </a:solidFill>
-            <a:prstDash val="solid"/>
-          </a:ln>
-        </p:spPr>
-      </p:sp>
-      <p:sp>
-        <p:nvSpPr>
-          <p:cNvPr id="28" name="Text 26"/>
-          <p:cNvSpPr/>
-          <p:nvPr/>
-        </p:nvSpPr>
-        <p:spPr>
-          <a:xfrm>
-            <a:off x="2766060" y="3108960"/>
-            <a:ext cx="475488" cy="475488"/>
-          </a:xfrm>
-          <a:prstGeom prst="rect">
-            <a:avLst/>
-          </a:prstGeom>
-          <a:noFill/>
-          <a:ln/>
-        </p:spPr>
-        <p:txBody>
-          <a:bodyPr wrap="square" lIns="0" tIns="0" rIns="0" bIns="0" rtlCol="0" anchor="ctr"/>
-          <a:lstStyle/>
-          <a:p>
-            <a:pPr algn="ctr" indent="0" marL="0">
-              <a:buNone/>
-            </a:pPr>
-            <a:r>
-              <a:rPr lang="en-US" sz="1500" b="1" dirty="0">
-                <a:solidFill>
-                  <a:srgbClr val="19D3E6"/>
-                </a:solidFill>
-                <a:latin typeface="Calibri" pitchFamily="34" charset="0"/>
-                <a:ea typeface="Calibri" pitchFamily="34" charset="-122"/>
-                <a:cs typeface="Calibri" pitchFamily="34" charset="-120"/>
-              </a:rPr>
-              <a:t>MI</a:t>
-            </a:r>
-            <a:endParaRPr lang="en-US" sz="1500" dirty="0"/>
-          </a:p>
-        </p:txBody>
-      </p:sp>
-      <p:sp>
-        <p:nvSpPr>
-          <p:cNvPr id="29" name="Text 27"/>
-          <p:cNvSpPr/>
-          <p:nvPr/>
-        </p:nvSpPr>
-        <p:spPr>
-          <a:xfrm>
-            <a:off x="2221992" y="3657600"/>
-            <a:ext cx="1563624" cy="411480"/>
-          </a:xfrm>
-          <a:prstGeom prst="rect">
-            <a:avLst/>
-          </a:prstGeom>
-          <a:noFill/>
-          <a:ln/>
-        </p:spPr>
-        <p:txBody>
-          <a:bodyPr wrap="square" lIns="0" tIns="0" rIns="0" bIns="0" rtlCol="0" anchor="t"/>
-          <a:lstStyle/>
-          <a:p>
-            <a:pPr algn="ctr" indent="0" marL="0">
-              <a:buNone/>
-            </a:pPr>
-            <a:r>
-              <a:rPr lang="en-US" sz="1250" b="1" dirty="0">
-                <a:solidFill>
-                  <a:srgbClr val="EAF4F8"/>
-                </a:solidFill>
-                <a:latin typeface="Calibri" pitchFamily="34" charset="0"/>
-                <a:ea typeface="Calibri" pitchFamily="34" charset="-122"/>
-                <a:cs typeface="Calibri" pitchFamily="34" charset="-120"/>
-              </a:rPr>
-              <a:t>Matheus Iverson</a:t>
-            </a:r>
-            <a:endParaRPr lang="en-US" sz="1250" dirty="0"/>
-          </a:p>
-        </p:txBody>
-      </p:sp>
-      <p:sp>
-        <p:nvSpPr>
-          <p:cNvPr id="30" name="Text 28"/>
-          <p:cNvSpPr/>
-          <p:nvPr/>
-        </p:nvSpPr>
-        <p:spPr>
-          <a:xfrm>
-            <a:off x="2221992" y="4059936"/>
-            <a:ext cx="1563624" cy="320040"/>
-          </a:xfrm>
-          <a:prstGeom prst="rect">
-            <a:avLst/>
-          </a:prstGeom>
-          <a:noFill/>
-          <a:ln/>
-        </p:spPr>
-        <p:txBody>
-          <a:bodyPr wrap="square" lIns="0" tIns="0" rIns="0" bIns="0" rtlCol="0" anchor="t"/>
-          <a:lstStyle/>
-          <a:p>
-            <a:pPr algn="ctr" indent="0" marL="0">
-              <a:buNone/>
-            </a:pPr>
-            <a:r>
-              <a:rPr lang="en-US" sz="1000" dirty="0">
-                <a:solidFill>
-                  <a:srgbClr val="8FA8B5"/>
-                </a:solidFill>
-                <a:latin typeface="Calibri" pitchFamily="34" charset="0"/>
-                <a:ea typeface="Calibri" pitchFamily="34" charset="-122"/>
-                <a:cs typeface="Calibri" pitchFamily="34" charset="-120"/>
-              </a:rPr>
-              <a:t>Dados / IA</a:t>
-            </a:r>
-            <a:endParaRPr lang="en-US" sz="1000" dirty="0"/>
-          </a:p>
-        </p:txBody>
-      </p:sp>
-      <p:sp>
-        <p:nvSpPr>
-          <p:cNvPr id="31" name="Shape 29"/>
-          <p:cNvSpPr/>
-          <p:nvPr/>
-        </p:nvSpPr>
-        <p:spPr>
-          <a:xfrm>
-            <a:off x="3877056" y="2926080"/>
-            <a:ext cx="1673352" cy="1508760"/>
-          </a:xfrm>
-          <a:prstGeom prst="roundRect">
-            <a:avLst>
-              <a:gd name="adj" fmla="val 5455"/>
-            </a:avLst>
-          </a:prstGeom>
-          <a:solidFill>
-            <a:srgbClr val="13313F"/>
-          </a:solidFill>
-          <a:ln w="12700">
-            <a:solidFill>
-              <a:srgbClr val="21485A"/>
-            </a:solidFill>
-            <a:prstDash val="solid"/>
-          </a:ln>
-          <a:effectLst>
-            <a:outerShdw sx="100000" sy="100000" kx="0" ky="0" algn="bl" rotWithShape="0" blurRad="88900" dist="38100" dir="5400000">
-              <a:srgbClr val="000000">
-                <a:alpha val="28000"/>
-              </a:srgbClr>
-            </a:outerShdw>
-          </a:effectLst>
-        </p:spPr>
-      </p:sp>
-      <p:sp>
-        <p:nvSpPr>
-          <p:cNvPr id="32" name="Shape 30"/>
-          <p:cNvSpPr/>
-          <p:nvPr/>
-        </p:nvSpPr>
-        <p:spPr>
-          <a:xfrm>
-            <a:off x="4475988" y="3108960"/>
-            <a:ext cx="475488" cy="475488"/>
-          </a:xfrm>
-          <a:prstGeom prst="ellipse">
-            <a:avLst/>
-          </a:prstGeom>
-          <a:solidFill>
-            <a:srgbClr val="0F2A38"/>
-          </a:solidFill>
-          <a:ln w="19050">
-            <a:solidFill>
-              <a:srgbClr val="19D3E6"/>
-            </a:solidFill>
-            <a:prstDash val="solid"/>
-          </a:ln>
-        </p:spPr>
-      </p:sp>
-      <p:sp>
-        <p:nvSpPr>
-          <p:cNvPr id="33" name="Text 31"/>
-          <p:cNvSpPr/>
-          <p:nvPr/>
-        </p:nvSpPr>
-        <p:spPr>
-          <a:xfrm>
-            <a:off x="4475988" y="3108960"/>
-            <a:ext cx="475488" cy="475488"/>
-          </a:xfrm>
-          <a:prstGeom prst="rect">
-            <a:avLst/>
-          </a:prstGeom>
-          <a:noFill/>
-          <a:ln/>
-        </p:spPr>
-        <p:txBody>
-          <a:bodyPr wrap="square" lIns="0" tIns="0" rIns="0" bIns="0" rtlCol="0" anchor="ctr"/>
-          <a:lstStyle/>
-          <a:p>
-            <a:pPr algn="ctr" indent="0" marL="0">
-              <a:buNone/>
-            </a:pPr>
-            <a:r>
-              <a:rPr lang="en-US" sz="1500" b="1" dirty="0">
-                <a:solidFill>
-                  <a:srgbClr val="19D3E6"/>
-                </a:solidFill>
-                <a:latin typeface="Calibri" pitchFamily="34" charset="0"/>
-                <a:ea typeface="Calibri" pitchFamily="34" charset="-122"/>
-                <a:cs typeface="Calibri" pitchFamily="34" charset="-120"/>
-              </a:rPr>
-              <a:t>DV</a:t>
-            </a:r>
-            <a:endParaRPr lang="en-US" sz="1500" dirty="0"/>
-          </a:p>
-        </p:txBody>
-      </p:sp>
-      <p:sp>
-        <p:nvSpPr>
-          <p:cNvPr id="34" name="Text 32"/>
-          <p:cNvSpPr/>
-          <p:nvPr/>
-        </p:nvSpPr>
-        <p:spPr>
-          <a:xfrm>
-            <a:off x="3931920" y="3657600"/>
-            <a:ext cx="1563624" cy="411480"/>
-          </a:xfrm>
-          <a:prstGeom prst="rect">
-            <a:avLst/>
-          </a:prstGeom>
-          <a:noFill/>
-          <a:ln/>
-        </p:spPr>
-        <p:txBody>
-          <a:bodyPr wrap="square" lIns="0" tIns="0" rIns="0" bIns="0" rtlCol="0" anchor="t"/>
-          <a:lstStyle/>
-          <a:p>
-            <a:pPr algn="ctr" indent="0" marL="0">
-              <a:buNone/>
-            </a:pPr>
-            <a:r>
-              <a:rPr lang="en-US" sz="1250" b="1" dirty="0">
-                <a:solidFill>
-                  <a:srgbClr val="EAF4F8"/>
-                </a:solidFill>
-                <a:latin typeface="Calibri" pitchFamily="34" charset="0"/>
-                <a:ea typeface="Calibri" pitchFamily="34" charset="-122"/>
-                <a:cs typeface="Calibri" pitchFamily="34" charset="-120"/>
-              </a:rPr>
-              <a:t>Daianne Valéria</a:t>
-            </a:r>
-            <a:endParaRPr lang="en-US" sz="1250" dirty="0"/>
-          </a:p>
-        </p:txBody>
-      </p:sp>
-      <p:sp>
-        <p:nvSpPr>
-          <p:cNvPr id="35" name="Text 33"/>
-          <p:cNvSpPr/>
-          <p:nvPr/>
-        </p:nvSpPr>
-        <p:spPr>
-          <a:xfrm>
-            <a:off x="3931920" y="4059936"/>
-            <a:ext cx="1563624" cy="320040"/>
-          </a:xfrm>
-          <a:prstGeom prst="rect">
-            <a:avLst/>
-          </a:prstGeom>
-          <a:noFill/>
-          <a:ln/>
-        </p:spPr>
-        <p:txBody>
-          <a:bodyPr wrap="square" lIns="0" tIns="0" rIns="0" bIns="0" rtlCol="0" anchor="t"/>
-          <a:lstStyle/>
-          <a:p>
-            <a:pPr algn="ctr" indent="0" marL="0">
-              <a:buNone/>
-            </a:pPr>
-            <a:r>
-              <a:rPr lang="en-US" sz="1000" dirty="0">
-                <a:solidFill>
-                  <a:srgbClr val="8FA8B5"/>
-                </a:solidFill>
-                <a:latin typeface="Calibri" pitchFamily="34" charset="0"/>
-                <a:ea typeface="Calibri" pitchFamily="34" charset="-122"/>
-                <a:cs typeface="Calibri" pitchFamily="34" charset="-120"/>
-              </a:rPr>
-              <a:t>Produto / UX</a:t>
-            </a:r>
-            <a:endParaRPr lang="en-US" sz="1000" dirty="0"/>
-          </a:p>
-        </p:txBody>
-      </p:sp>
-      <p:sp>
-        <p:nvSpPr>
-          <p:cNvPr id="36" name="Shape 34"/>
-          <p:cNvSpPr/>
-          <p:nvPr/>
-        </p:nvSpPr>
-        <p:spPr>
-          <a:xfrm>
-            <a:off x="5586984" y="2926080"/>
-            <a:ext cx="1673352" cy="1508760"/>
-          </a:xfrm>
-          <a:prstGeom prst="roundRect">
-            <a:avLst>
-              <a:gd name="adj" fmla="val 5455"/>
-            </a:avLst>
-          </a:prstGeom>
-          <a:solidFill>
-            <a:srgbClr val="13313F"/>
-          </a:solidFill>
-          <a:ln w="12700">
-            <a:solidFill>
-              <a:srgbClr val="21485A"/>
-            </a:solidFill>
-            <a:prstDash val="solid"/>
-          </a:ln>
-          <a:effectLst>
-            <a:outerShdw sx="100000" sy="100000" kx="0" ky="0" algn="bl" rotWithShape="0" blurRad="88900" dist="38100" dir="5400000">
-              <a:srgbClr val="000000">
-                <a:alpha val="28000"/>
-              </a:srgbClr>
-            </a:outerShdw>
-          </a:effectLst>
-        </p:spPr>
-      </p:sp>
-      <p:sp>
-        <p:nvSpPr>
-          <p:cNvPr id="37" name="Shape 35"/>
-          <p:cNvSpPr/>
-          <p:nvPr/>
-        </p:nvSpPr>
-        <p:spPr>
-          <a:xfrm>
-            <a:off x="6185916" y="3108960"/>
-            <a:ext cx="475488" cy="475488"/>
-          </a:xfrm>
-          <a:prstGeom prst="ellipse">
-            <a:avLst/>
-          </a:prstGeom>
-          <a:solidFill>
-            <a:srgbClr val="0F2A38"/>
-          </a:solidFill>
-          <a:ln w="19050">
-            <a:solidFill>
-              <a:srgbClr val="34D399"/>
-            </a:solidFill>
-            <a:prstDash val="solid"/>
-          </a:ln>
-        </p:spPr>
-      </p:sp>
-      <p:sp>
-        <p:nvSpPr>
-          <p:cNvPr id="38" name="Text 36"/>
-          <p:cNvSpPr/>
-          <p:nvPr/>
-        </p:nvSpPr>
-        <p:spPr>
-          <a:xfrm>
-            <a:off x="6185916" y="3108960"/>
-            <a:ext cx="475488" cy="475488"/>
-          </a:xfrm>
-          <a:prstGeom prst="rect">
-            <a:avLst/>
-          </a:prstGeom>
-          <a:noFill/>
-          <a:ln/>
-        </p:spPr>
-        <p:txBody>
-          <a:bodyPr wrap="square" lIns="0" tIns="0" rIns="0" bIns="0" rtlCol="0" anchor="ctr"/>
-          <a:lstStyle/>
-          <a:p>
-            <a:pPr algn="ctr" indent="0" marL="0">
-              <a:buNone/>
-            </a:pPr>
-            <a:r>
-              <a:rPr lang="en-US" sz="1500" b="1" dirty="0">
-                <a:solidFill>
-                  <a:srgbClr val="34D399"/>
-                </a:solidFill>
-                <a:latin typeface="Calibri" pitchFamily="34" charset="0"/>
-                <a:ea typeface="Calibri" pitchFamily="34" charset="-122"/>
-                <a:cs typeface="Calibri" pitchFamily="34" charset="-120"/>
-              </a:rPr>
-              <a:t>MV</a:t>
-            </a:r>
-            <a:endParaRPr lang="en-US" sz="1500" dirty="0"/>
-          </a:p>
-        </p:txBody>
-      </p:sp>
-      <p:sp>
-        <p:nvSpPr>
-          <p:cNvPr id="39" name="Text 37"/>
-          <p:cNvSpPr/>
-          <p:nvPr/>
-        </p:nvSpPr>
-        <p:spPr>
-          <a:xfrm>
-            <a:off x="5641848" y="3657600"/>
-            <a:ext cx="1563624" cy="411480"/>
-          </a:xfrm>
-          <a:prstGeom prst="rect">
-            <a:avLst/>
-          </a:prstGeom>
-          <a:noFill/>
-          <a:ln/>
-        </p:spPr>
-        <p:txBody>
-          <a:bodyPr wrap="square" lIns="0" tIns="0" rIns="0" bIns="0" rtlCol="0" anchor="t"/>
-          <a:lstStyle/>
-          <a:p>
-            <a:pPr algn="ctr" indent="0" marL="0">
-              <a:buNone/>
-            </a:pPr>
-            <a:r>
-              <a:rPr lang="en-US" sz="1250" b="1" dirty="0">
-                <a:solidFill>
-                  <a:srgbClr val="EAF4F8"/>
-                </a:solidFill>
-                <a:latin typeface="Calibri" pitchFamily="34" charset="0"/>
-                <a:ea typeface="Calibri" pitchFamily="34" charset="-122"/>
-                <a:cs typeface="Calibri" pitchFamily="34" charset="-120"/>
-              </a:rPr>
-              <a:t>Maria Vitória</a:t>
-            </a:r>
-            <a:endParaRPr lang="en-US" sz="1250" dirty="0"/>
-          </a:p>
-        </p:txBody>
-      </p:sp>
-      <p:sp>
-        <p:nvSpPr>
-          <p:cNvPr id="40" name="Text 38"/>
-          <p:cNvSpPr/>
-          <p:nvPr/>
-        </p:nvSpPr>
-        <p:spPr>
-          <a:xfrm>
-            <a:off x="5641848" y="4059936"/>
-            <a:ext cx="1563624" cy="320040"/>
-          </a:xfrm>
-          <a:prstGeom prst="rect">
-            <a:avLst/>
-          </a:prstGeom>
-          <a:noFill/>
-          <a:ln/>
-        </p:spPr>
-        <p:txBody>
-          <a:bodyPr wrap="square" lIns="0" tIns="0" rIns="0" bIns="0" rtlCol="0" anchor="t"/>
-          <a:lstStyle/>
-          <a:p>
-            <a:pPr algn="ctr" indent="0" marL="0">
-              <a:buNone/>
-            </a:pPr>
-            <a:r>
-              <a:rPr lang="en-US" sz="1000" dirty="0">
-                <a:solidFill>
-                  <a:srgbClr val="8FA8B5"/>
-                </a:solidFill>
-                <a:latin typeface="Calibri" pitchFamily="34" charset="0"/>
-                <a:ea typeface="Calibri" pitchFamily="34" charset="-122"/>
-                <a:cs typeface="Calibri" pitchFamily="34" charset="-120"/>
-              </a:rPr>
-              <a:t>Veterinária</a:t>
-            </a:r>
-            <a:endParaRPr lang="en-US" sz="1000" dirty="0"/>
-          </a:p>
-        </p:txBody>
-      </p:sp>
-      <p:sp>
-        <p:nvSpPr>
-          <p:cNvPr id="41" name="Shape 39"/>
-          <p:cNvSpPr/>
-          <p:nvPr/>
-        </p:nvSpPr>
-        <p:spPr>
-          <a:xfrm>
-            <a:off x="7296912" y="2926080"/>
-            <a:ext cx="1673352" cy="1508760"/>
-          </a:xfrm>
-          <a:prstGeom prst="roundRect">
-            <a:avLst>
-              <a:gd name="adj" fmla="val 5455"/>
-            </a:avLst>
-          </a:prstGeom>
-          <a:solidFill>
-            <a:srgbClr val="13313F"/>
-          </a:solidFill>
-          <a:ln w="12700">
-            <a:solidFill>
-              <a:srgbClr val="21485A"/>
-            </a:solidFill>
-            <a:prstDash val="solid"/>
-          </a:ln>
-          <a:effectLst>
-            <a:outerShdw sx="100000" sy="100000" kx="0" ky="0" algn="bl" rotWithShape="0" blurRad="88900" dist="38100" dir="5400000">
-              <a:srgbClr val="000000">
-                <a:alpha val="28000"/>
-              </a:srgbClr>
-            </a:outerShdw>
-          </a:effectLst>
-        </p:spPr>
-      </p:sp>
-      <p:sp>
-        <p:nvSpPr>
-          <p:cNvPr id="42" name="Shape 40"/>
-          <p:cNvSpPr/>
-          <p:nvPr/>
-        </p:nvSpPr>
-        <p:spPr>
-          <a:xfrm>
-            <a:off x="7895844" y="3108960"/>
-            <a:ext cx="475488" cy="475488"/>
-          </a:xfrm>
-          <a:prstGeom prst="ellipse">
-            <a:avLst/>
-          </a:prstGeom>
-          <a:solidFill>
-            <a:srgbClr val="0F2A38"/>
-          </a:solidFill>
-          <a:ln w="19050">
-            <a:solidFill>
-              <a:srgbClr val="34D399"/>
-            </a:solidFill>
-            <a:prstDash val="solid"/>
-          </a:ln>
-        </p:spPr>
-      </p:sp>
-      <p:sp>
-        <p:nvSpPr>
-          <p:cNvPr id="43" name="Text 41"/>
-          <p:cNvSpPr/>
-          <p:nvPr/>
-        </p:nvSpPr>
-        <p:spPr>
-          <a:xfrm>
-            <a:off x="7895844" y="3108960"/>
-            <a:ext cx="475488" cy="475488"/>
-          </a:xfrm>
-          <a:prstGeom prst="rect">
-            <a:avLst/>
-          </a:prstGeom>
-          <a:noFill/>
-          <a:ln/>
-        </p:spPr>
-        <p:txBody>
-          <a:bodyPr wrap="square" lIns="0" tIns="0" rIns="0" bIns="0" rtlCol="0" anchor="ctr"/>
-          <a:lstStyle/>
-          <a:p>
-            <a:pPr algn="ctr" indent="0" marL="0">
-              <a:buNone/>
-            </a:pPr>
-            <a:r>
-              <a:rPr lang="en-US" sz="1500" b="1" dirty="0">
-                <a:solidFill>
-                  <a:srgbClr val="34D399"/>
-                </a:solidFill>
-                <a:latin typeface="Calibri" pitchFamily="34" charset="0"/>
-                <a:ea typeface="Calibri" pitchFamily="34" charset="-122"/>
-                <a:cs typeface="Calibri" pitchFamily="34" charset="-120"/>
-              </a:rPr>
-              <a:t>DS</a:t>
-            </a:r>
-            <a:endParaRPr lang="en-US" sz="1500" dirty="0"/>
-          </a:p>
-        </p:txBody>
-      </p:sp>
-      <p:sp>
-        <p:nvSpPr>
-          <p:cNvPr id="44" name="Text 42"/>
-          <p:cNvSpPr/>
-          <p:nvPr/>
-        </p:nvSpPr>
-        <p:spPr>
-          <a:xfrm>
-            <a:off x="7351776" y="3657600"/>
-            <a:ext cx="1563624" cy="411480"/>
-          </a:xfrm>
-          <a:prstGeom prst="rect">
-            <a:avLst/>
-          </a:prstGeom>
-          <a:noFill/>
-          <a:ln/>
-        </p:spPr>
-        <p:txBody>
-          <a:bodyPr wrap="square" lIns="0" tIns="0" rIns="0" bIns="0" rtlCol="0" anchor="t"/>
-          <a:lstStyle/>
-          <a:p>
-            <a:pPr algn="ctr" indent="0" marL="0">
-              <a:buNone/>
-            </a:pPr>
-            <a:r>
-              <a:rPr lang="en-US" sz="1250" b="1" dirty="0">
-                <a:solidFill>
-                  <a:srgbClr val="EAF4F8"/>
-                </a:solidFill>
-                <a:latin typeface="Calibri" pitchFamily="34" charset="0"/>
-                <a:ea typeface="Calibri" pitchFamily="34" charset="-122"/>
-                <a:cs typeface="Calibri" pitchFamily="34" charset="-120"/>
-              </a:rPr>
-              <a:t>Diego Santana</a:t>
-            </a:r>
-            <a:endParaRPr lang="en-US" sz="1250" dirty="0"/>
-          </a:p>
-        </p:txBody>
-      </p:sp>
-      <p:sp>
-        <p:nvSpPr>
-          <p:cNvPr id="45" name="Text 43"/>
-          <p:cNvSpPr/>
-          <p:nvPr/>
-        </p:nvSpPr>
-        <p:spPr>
-          <a:xfrm>
-            <a:off x="7351776" y="4059936"/>
-            <a:ext cx="1563624" cy="320040"/>
-          </a:xfrm>
-          <a:prstGeom prst="rect">
-            <a:avLst/>
-          </a:prstGeom>
-          <a:noFill/>
-          <a:ln/>
-        </p:spPr>
-        <p:txBody>
-          <a:bodyPr wrap="square" lIns="0" tIns="0" rIns="0" bIns="0" rtlCol="0" anchor="t"/>
-          <a:lstStyle/>
-          <a:p>
-            <a:pPr algn="ctr" indent="0" marL="0">
-              <a:buNone/>
-            </a:pPr>
-            <a:r>
-              <a:rPr lang="en-US" sz="1000" dirty="0">
-                <a:solidFill>
-                  <a:srgbClr val="8FA8B5"/>
-                </a:solidFill>
-                <a:latin typeface="Calibri" pitchFamily="34" charset="0"/>
-                <a:ea typeface="Calibri" pitchFamily="34" charset="-122"/>
-                <a:cs typeface="Calibri" pitchFamily="34" charset="-120"/>
-              </a:rPr>
-              <a:t>Eng. Software</a:t>
-            </a:r>
-            <a:endParaRPr lang="en-US" sz="1000" dirty="0"/>
+              <a:t>Sensores · tempo real</a:t>
+            </a:r>
+            <a:endParaRPr lang="en-US" sz="1200" dirty="0"/>
           </a:p>
         </p:txBody>
       </p:sp>
@@ -6790,6 +6241,62 @@
 <file path=ppt/slides/slide8.xml><?xml version="1.0" encoding="utf-8"?>
 <p:sld xmlns:a="http://schemas.openxmlformats.org/drawingml/2006/main" xmlns:r="http://schemas.openxmlformats.org/officeDocument/2006/relationships" xmlns:p="http://schemas.openxmlformats.org/presentationml/2006/main">
   <p:cSld name="Slide 8">
+    <p:bg>
+      <p:bgPr>
+        <a:solidFill>
+          <a:srgbClr val="08161F"/>
+        </a:solidFill>
+      </p:bgPr>
+    </p:bg>
+    <p:spTree>
+      <p:nvGrpSpPr>
+        <p:cNvPr id="1" name=""/>
+        <p:cNvGrpSpPr/>
+        <p:nvPr/>
+      </p:nvGrpSpPr>
+      <p:grpSpPr>
+        <a:xfrm>
+          <a:off x="0" y="0"/>
+          <a:ext cx="0" cy="0"/>
+          <a:chOff x="0" y="0"/>
+          <a:chExt cx="0" cy="0"/>
+        </a:xfrm>
+      </p:grpSpPr>
+      <p:pic>
+        <p:nvPicPr>
+          <p:cNvPr id="2" name="Image 0" descr="C:/Users/Novou/Desktop/USINA/Via Leite/prototipo/assets/equipe.png">    </p:cNvPr>
+          <p:cNvPicPr>
+            <a:picLocks noChangeAspect="1"/>
+          </p:cNvPicPr>
+          <p:nvPr/>
+        </p:nvPicPr>
+        <p:blipFill>
+          <a:blip r:embed="rId1"/>
+          <a:stretch>
+            <a:fillRect/>
+          </a:stretch>
+        </p:blipFill>
+        <p:spPr>
+          <a:xfrm>
+            <a:off x="0" y="21031"/>
+            <a:ext cx="9144000" cy="5100523"/>
+          </a:xfrm>
+          <a:prstGeom prst="rect">
+            <a:avLst/>
+          </a:prstGeom>
+        </p:spPr>
+      </p:pic>
+    </p:spTree>
+  </p:cSld>
+  <p:clrMapOvr>
+    <a:masterClrMapping/>
+  </p:clrMapOvr>
+</p:sld>
+</file>
+
+<file path=ppt/slides/slide9.xml><?xml version="1.0" encoding="utf-8"?>
+<p:sld xmlns:a="http://schemas.openxmlformats.org/drawingml/2006/main" xmlns:r="http://schemas.openxmlformats.org/officeDocument/2006/relationships" xmlns:p="http://schemas.openxmlformats.org/presentationml/2006/main">
+  <p:cSld name="Slide 9">
     <p:bg>
       <p:bgPr>
         <a:solidFill>

</xml_diff>